<commit_message>
🐛 fix(template-placeholder): correct placeholder positions in blank templates
Updated placeholder positions in blank-dark.pptx and blank-light.pptx
</commit_message>
<xml_diff>
--- a/skill/templates/blank-dark.pptx
+++ b/skill/templates/blank-dark.pptx
@@ -209,7 +209,7 @@
           <a:p>
             <a:fld id="{D18FD1B0-74F3-D141-B210-936319A276C7}" type="datetimeFigureOut">
               <a:rPr kumimoji="1" lang="ja-JP" altLang="en-US" smtClean="0"/>
-              <a:t>2026/4/11</a:t>
+              <a:t>2026/4/21</a:t>
             </a:fld>
             <a:endParaRPr kumimoji="1" lang="ja-JP" altLang="en-US"/>
           </a:p>
@@ -859,7 +859,7 @@
           <a:p>
             <a:fld id="{5BCAD085-E8A6-8845-BD4E-CB4CCA059FC4}" type="datetimeFigureOut">
               <a:rPr lang="en-US" smtClean="0"/>
-              <a:t>4/11/26</a:t>
+              <a:t>4/21/26</a:t>
             </a:fld>
             <a:endParaRPr lang="en-US"/>
           </a:p>
@@ -1027,7 +1027,7 @@
           <a:p>
             <a:fld id="{5BCAD085-E8A6-8845-BD4E-CB4CCA059FC4}" type="datetimeFigureOut">
               <a:rPr lang="en-US" smtClean="0"/>
-              <a:t>4/11/26</a:t>
+              <a:t>4/21/26</a:t>
             </a:fld>
             <a:endParaRPr lang="en-US"/>
           </a:p>
@@ -1205,7 +1205,7 @@
           <a:p>
             <a:fld id="{5BCAD085-E8A6-8845-BD4E-CB4CCA059FC4}" type="datetimeFigureOut">
               <a:rPr lang="en-US" smtClean="0"/>
-              <a:t>4/11/26</a:t>
+              <a:t>4/21/26</a:t>
             </a:fld>
             <a:endParaRPr lang="en-US"/>
           </a:p>
@@ -1373,7 +1373,7 @@
           <a:p>
             <a:fld id="{5BCAD085-E8A6-8845-BD4E-CB4CCA059FC4}" type="datetimeFigureOut">
               <a:rPr lang="en-US" smtClean="0"/>
-              <a:t>4/11/26</a:t>
+              <a:t>4/21/26</a:t>
             </a:fld>
             <a:endParaRPr lang="en-US"/>
           </a:p>
@@ -1618,7 +1618,7 @@
           <a:p>
             <a:fld id="{5BCAD085-E8A6-8845-BD4E-CB4CCA059FC4}" type="datetimeFigureOut">
               <a:rPr lang="en-US" smtClean="0"/>
-              <a:t>4/11/26</a:t>
+              <a:t>4/21/26</a:t>
             </a:fld>
             <a:endParaRPr lang="en-US"/>
           </a:p>
@@ -1903,7 +1903,7 @@
           <a:p>
             <a:fld id="{5BCAD085-E8A6-8845-BD4E-CB4CCA059FC4}" type="datetimeFigureOut">
               <a:rPr lang="en-US" smtClean="0"/>
-              <a:t>4/11/26</a:t>
+              <a:t>4/21/26</a:t>
             </a:fld>
             <a:endParaRPr lang="en-US"/>
           </a:p>
@@ -2322,7 +2322,7 @@
           <a:p>
             <a:fld id="{5BCAD085-E8A6-8845-BD4E-CB4CCA059FC4}" type="datetimeFigureOut">
               <a:rPr lang="en-US" smtClean="0"/>
-              <a:t>4/11/26</a:t>
+              <a:t>4/21/26</a:t>
             </a:fld>
             <a:endParaRPr lang="en-US"/>
           </a:p>
@@ -2412,7 +2412,7 @@
         </p:nvSpPr>
         <p:spPr>
           <a:xfrm>
-            <a:off x="457200" y="413786"/>
+            <a:off x="457200" y="284578"/>
             <a:ext cx="10992678" cy="798788"/>
           </a:xfrm>
         </p:spPr>
@@ -2450,7 +2450,7 @@
           <a:p>
             <a:fld id="{5BCAD085-E8A6-8845-BD4E-CB4CCA059FC4}" type="datetimeFigureOut">
               <a:rPr lang="en-US" smtClean="0"/>
-              <a:t>4/11/26</a:t>
+              <a:t>4/21/26</a:t>
             </a:fld>
             <a:endParaRPr lang="en-US"/>
           </a:p>
@@ -2553,7 +2553,7 @@
           <a:p>
             <a:fld id="{5BCAD085-E8A6-8845-BD4E-CB4CCA059FC4}" type="datetimeFigureOut">
               <a:rPr lang="en-US" smtClean="0"/>
-              <a:t>4/11/26</a:t>
+              <a:t>4/21/26</a:t>
             </a:fld>
             <a:endParaRPr lang="en-US"/>
           </a:p>
@@ -2828,7 +2828,7 @@
           <a:p>
             <a:fld id="{5BCAD085-E8A6-8845-BD4E-CB4CCA059FC4}" type="datetimeFigureOut">
               <a:rPr lang="en-US" smtClean="0"/>
-              <a:t>4/11/26</a:t>
+              <a:t>4/21/26</a:t>
             </a:fld>
             <a:endParaRPr lang="en-US"/>
           </a:p>
@@ -3080,7 +3080,7 @@
           <a:p>
             <a:fld id="{5BCAD085-E8A6-8845-BD4E-CB4CCA059FC4}" type="datetimeFigureOut">
               <a:rPr lang="en-US" smtClean="0"/>
-              <a:t>4/11/26</a:t>
+              <a:t>4/21/26</a:t>
             </a:fld>
             <a:endParaRPr lang="en-US"/>
           </a:p>
@@ -3291,7 +3291,7 @@
           <a:p>
             <a:fld id="{5BCAD085-E8A6-8845-BD4E-CB4CCA059FC4}" type="datetimeFigureOut">
               <a:rPr lang="en-US" smtClean="0"/>
-              <a:t>4/11/26</a:t>
+              <a:t>4/21/26</a:t>
             </a:fld>
             <a:endParaRPr lang="en-US"/>
           </a:p>
@@ -3748,10 +3748,10 @@
       </p:grpSpPr>
       <p:sp>
         <p:nvSpPr>
-          <p:cNvPr id="2" name="タイトル 1">
+          <p:cNvPr id="8" name="タイトル 7">
             <a:extLst>
               <a:ext uri="{FF2B5EF4-FFF2-40B4-BE49-F238E27FC236}">
-                <a16:creationId xmlns:a16="http://schemas.microsoft.com/office/drawing/2014/main" id="{2C15A3F2-8970-CA77-3AB2-93673E2DA7CF}"/>
+                <a16:creationId xmlns:a16="http://schemas.microsoft.com/office/drawing/2014/main" id="{203BA0AA-32D2-FF54-9A31-CE3C040EA7F8}"/>
               </a:ext>
             </a:extLst>
           </p:cNvPr>
@@ -3762,17 +3762,12 @@
             <p:ph type="title"/>
           </p:nvPr>
         </p:nvSpPr>
-        <p:spPr>
-          <a:xfrm>
-            <a:off x="457200" y="298172"/>
-            <a:ext cx="10992678" cy="798788"/>
-          </a:xfrm>
-        </p:spPr>
-        <p:txBody>
-          <a:bodyPr/>
-          <a:lstStyle/>
-          <a:p>
-            <a:endParaRPr kumimoji="1" lang="ja-JP" altLang="en-US"/>
+        <p:spPr/>
+        <p:txBody>
+          <a:bodyPr/>
+          <a:lstStyle/>
+          <a:p>
+            <a:endParaRPr lang="ja-JP" altLang="en-US"/>
           </a:p>
         </p:txBody>
       </p:sp>

</xml_diff>